<commit_message>
Update Analysis of Us Rental Market.pptx
</commit_message>
<xml_diff>
--- a/Analysis of Us Rental Market.pptx
+++ b/Analysis of Us Rental Market.pptx
@@ -209,7 +209,7 @@
           <a:p>
             <a:fld id="{D813B696-7300-B942-95CD-6BA9CF4A8F92}" type="datetimeFigureOut">
               <a:rPr lang="en-US" smtClean="0"/>
-              <a:t>3/2/26</a:t>
+              <a:t>3/12/26</a:t>
             </a:fld>
             <a:endParaRPr lang="en-US"/>
           </a:p>
@@ -623,7 +623,7 @@
             </a:pPr>
             <a:r>
               <a:rPr lang="en-US" dirty="0"/>
-              <a:t xml:space="preserve">Sports amenities include: </a:t>
+              <a:t>Sports amenities include: </a:t>
             </a:r>
             <a:r>
               <a:rPr lang="en-US" b="0" dirty="0">
@@ -643,7 +643,7 @@
                 <a:effectLst/>
                 <a:latin typeface="Courier New" panose="02070309020205020404" pitchFamily="49" charset="0"/>
               </a:rPr>
-              <a:t xml:space="preserve">, </a:t>
+              <a:t>, </a:t>
             </a:r>
             <a:r>
               <a:rPr lang="en-US" b="0" dirty="0">
@@ -663,7 +663,7 @@
                 <a:effectLst/>
                 <a:latin typeface="Courier New" panose="02070309020205020404" pitchFamily="49" charset="0"/>
               </a:rPr>
-              <a:t xml:space="preserve">, </a:t>
+              <a:t>, </a:t>
             </a:r>
             <a:r>
               <a:rPr lang="en-US" b="0" dirty="0">
@@ -683,7 +683,7 @@
                 <a:effectLst/>
                 <a:latin typeface="Courier New" panose="02070309020205020404" pitchFamily="49" charset="0"/>
               </a:rPr>
-              <a:t xml:space="preserve">, </a:t>
+              <a:t>, </a:t>
             </a:r>
             <a:r>
               <a:rPr lang="en-US" b="0" dirty="0">
@@ -703,7 +703,7 @@
                 <a:effectLst/>
                 <a:latin typeface="Courier New" panose="02070309020205020404" pitchFamily="49" charset="0"/>
               </a:rPr>
-              <a:t xml:space="preserve">, </a:t>
+              <a:t>, </a:t>
             </a:r>
             <a:r>
               <a:rPr lang="en-US" b="0" dirty="0">
@@ -752,7 +752,7 @@
                 <a:effectLst/>
                 <a:latin typeface="Courier New" panose="02070309020205020404" pitchFamily="49" charset="0"/>
               </a:rPr>
-              <a:t xml:space="preserve">, </a:t>
+              <a:t>, </a:t>
             </a:r>
             <a:r>
               <a:rPr lang="en-US" b="0" dirty="0">
@@ -772,7 +772,7 @@
                 <a:effectLst/>
                 <a:latin typeface="Courier New" panose="02070309020205020404" pitchFamily="49" charset="0"/>
               </a:rPr>
-              <a:t xml:space="preserve">, </a:t>
+              <a:t>, </a:t>
             </a:r>
             <a:r>
               <a:rPr lang="en-US" b="0" dirty="0">
@@ -811,7 +811,7 @@
                 <a:effectLst/>
                 <a:latin typeface="Courier New" panose="02070309020205020404" pitchFamily="49" charset="0"/>
               </a:rPr>
-              <a:t xml:space="preserve">Convenience </a:t>
+              <a:t>Convenience </a:t>
             </a:r>
             <a:r>
               <a:rPr lang="en-US" b="0" dirty="0">
@@ -831,7 +831,7 @@
                 <a:effectLst/>
                 <a:latin typeface="Courier New" panose="02070309020205020404" pitchFamily="49" charset="0"/>
               </a:rPr>
-              <a:t xml:space="preserve">, </a:t>
+              <a:t>, </a:t>
             </a:r>
             <a:r>
               <a:rPr lang="en-US" b="0" dirty="0">
@@ -851,7 +851,7 @@
                 <a:effectLst/>
                 <a:latin typeface="Courier New" panose="02070309020205020404" pitchFamily="49" charset="0"/>
               </a:rPr>
-              <a:t xml:space="preserve">, </a:t>
+              <a:t>, </a:t>
             </a:r>
             <a:r>
               <a:rPr lang="en-US" b="0" dirty="0">
@@ -871,7 +871,7 @@
                 <a:effectLst/>
                 <a:latin typeface="Courier New" panose="02070309020205020404" pitchFamily="49" charset="0"/>
               </a:rPr>
-              <a:t xml:space="preserve">, </a:t>
+              <a:t>, </a:t>
             </a:r>
             <a:r>
               <a:rPr lang="en-US" b="0" dirty="0">
@@ -891,7 +891,7 @@
                 <a:effectLst/>
                 <a:latin typeface="Courier New" panose="02070309020205020404" pitchFamily="49" charset="0"/>
               </a:rPr>
-              <a:t xml:space="preserve">, </a:t>
+              <a:t>, </a:t>
             </a:r>
             <a:r>
               <a:rPr lang="en-US" b="0" dirty="0">
@@ -911,7 +911,7 @@
                 <a:effectLst/>
                 <a:latin typeface="Courier New" panose="02070309020205020404" pitchFamily="49" charset="0"/>
               </a:rPr>
-              <a:t xml:space="preserve">, </a:t>
+              <a:t>, </a:t>
             </a:r>
             <a:r>
               <a:rPr lang="en-US" b="0" dirty="0">
@@ -931,7 +931,7 @@
                 <a:effectLst/>
                 <a:latin typeface="Courier New" panose="02070309020205020404" pitchFamily="49" charset="0"/>
               </a:rPr>
-              <a:t xml:space="preserve">, </a:t>
+              <a:t>, </a:t>
             </a:r>
             <a:r>
               <a:rPr lang="en-US" b="0" dirty="0">
@@ -951,7 +951,7 @@
                 <a:effectLst/>
                 <a:latin typeface="Courier New" panose="02070309020205020404" pitchFamily="49" charset="0"/>
               </a:rPr>
-              <a:t xml:space="preserve">, </a:t>
+              <a:t>, </a:t>
             </a:r>
             <a:r>
               <a:rPr lang="en-US" b="0" dirty="0">
@@ -971,7 +971,7 @@
                 <a:effectLst/>
                 <a:latin typeface="Courier New" panose="02070309020205020404" pitchFamily="49" charset="0"/>
               </a:rPr>
-              <a:t xml:space="preserve">, </a:t>
+              <a:t>, </a:t>
             </a:r>
             <a:r>
               <a:rPr lang="en-US" b="0" dirty="0" err="1">
@@ -1011,7 +1011,7 @@
                 <a:effectLst/>
                 <a:latin typeface="Courier New" panose="02070309020205020404" pitchFamily="49" charset="0"/>
               </a:rPr>
-              <a:t xml:space="preserve"> or </a:t>
+              <a:t> or </a:t>
             </a:r>
             <a:r>
               <a:rPr lang="en-US" b="0" dirty="0" err="1">
@@ -1051,7 +1051,7 @@
                 <a:effectLst/>
                 <a:latin typeface="Courier New" panose="02070309020205020404" pitchFamily="49" charset="0"/>
               </a:rPr>
-              <a:t xml:space="preserve"> Access</a:t>
+              <a:t> Access</a:t>
             </a:r>
           </a:p>
           <a:p>
@@ -1090,7 +1090,7 @@
                 <a:effectLst/>
                 <a:latin typeface="Courier New" panose="02070309020205020404" pitchFamily="49" charset="0"/>
               </a:rPr>
-              <a:t xml:space="preserve">, </a:t>
+              <a:t>, </a:t>
             </a:r>
             <a:r>
               <a:rPr lang="en-US" b="0" dirty="0">
@@ -1110,7 +1110,7 @@
                 <a:effectLst/>
                 <a:latin typeface="Courier New" panose="02070309020205020404" pitchFamily="49" charset="0"/>
               </a:rPr>
-              <a:t xml:space="preserve">, </a:t>
+              <a:t>, </a:t>
             </a:r>
             <a:r>
               <a:rPr lang="en-US" b="0" dirty="0">
@@ -1130,7 +1130,7 @@
                 <a:effectLst/>
                 <a:latin typeface="Courier New" panose="02070309020205020404" pitchFamily="49" charset="0"/>
               </a:rPr>
-              <a:t xml:space="preserve">, </a:t>
+              <a:t>, </a:t>
             </a:r>
             <a:r>
               <a:rPr lang="en-US" b="0" dirty="0">
@@ -1150,7 +1150,7 @@
                 <a:effectLst/>
                 <a:latin typeface="Courier New" panose="02070309020205020404" pitchFamily="49" charset="0"/>
               </a:rPr>
-              <a:t xml:space="preserve">, </a:t>
+              <a:t>, </a:t>
             </a:r>
             <a:r>
               <a:rPr lang="en-US" b="0" dirty="0">
@@ -1170,7 +1170,7 @@
                 <a:effectLst/>
                 <a:latin typeface="Courier New" panose="02070309020205020404" pitchFamily="49" charset="0"/>
               </a:rPr>
-              <a:t xml:space="preserve">, </a:t>
+              <a:t>, </a:t>
             </a:r>
             <a:r>
               <a:rPr lang="en-US" b="0" dirty="0">
@@ -1424,7 +1424,7 @@
             </a:pPr>
             <a:r>
               <a:rPr lang="en-US" dirty="0"/>
-              <a:t xml:space="preserve">Sports amenities include: </a:t>
+              <a:t>Sports amenities include: </a:t>
             </a:r>
             <a:r>
               <a:rPr lang="en-US" b="0" dirty="0">
@@ -1444,7 +1444,7 @@
                 <a:effectLst/>
                 <a:latin typeface="Courier New" panose="02070309020205020404" pitchFamily="49" charset="0"/>
               </a:rPr>
-              <a:t xml:space="preserve">, </a:t>
+              <a:t>, </a:t>
             </a:r>
             <a:r>
               <a:rPr lang="en-US" b="0" dirty="0">
@@ -1464,7 +1464,7 @@
                 <a:effectLst/>
                 <a:latin typeface="Courier New" panose="02070309020205020404" pitchFamily="49" charset="0"/>
               </a:rPr>
-              <a:t xml:space="preserve">, </a:t>
+              <a:t>, </a:t>
             </a:r>
             <a:r>
               <a:rPr lang="en-US" b="0" dirty="0">
@@ -1484,7 +1484,7 @@
                 <a:effectLst/>
                 <a:latin typeface="Courier New" panose="02070309020205020404" pitchFamily="49" charset="0"/>
               </a:rPr>
-              <a:t xml:space="preserve">, </a:t>
+              <a:t>, </a:t>
             </a:r>
             <a:r>
               <a:rPr lang="en-US" b="0" dirty="0">
@@ -1504,7 +1504,7 @@
                 <a:effectLst/>
                 <a:latin typeface="Courier New" panose="02070309020205020404" pitchFamily="49" charset="0"/>
               </a:rPr>
-              <a:t xml:space="preserve">, </a:t>
+              <a:t>, </a:t>
             </a:r>
             <a:r>
               <a:rPr lang="en-US" b="0" dirty="0">
@@ -1553,7 +1553,7 @@
                 <a:effectLst/>
                 <a:latin typeface="Courier New" panose="02070309020205020404" pitchFamily="49" charset="0"/>
               </a:rPr>
-              <a:t xml:space="preserve">, </a:t>
+              <a:t>, </a:t>
             </a:r>
             <a:r>
               <a:rPr lang="en-US" b="0" dirty="0">
@@ -1573,7 +1573,7 @@
                 <a:effectLst/>
                 <a:latin typeface="Courier New" panose="02070309020205020404" pitchFamily="49" charset="0"/>
               </a:rPr>
-              <a:t xml:space="preserve">, </a:t>
+              <a:t>, </a:t>
             </a:r>
             <a:r>
               <a:rPr lang="en-US" b="0" dirty="0">
@@ -1612,7 +1612,7 @@
                 <a:effectLst/>
                 <a:latin typeface="Courier New" panose="02070309020205020404" pitchFamily="49" charset="0"/>
               </a:rPr>
-              <a:t xml:space="preserve">Convenience </a:t>
+              <a:t>Convenience </a:t>
             </a:r>
             <a:r>
               <a:rPr lang="en-US" b="0" dirty="0">
@@ -1632,7 +1632,7 @@
                 <a:effectLst/>
                 <a:latin typeface="Courier New" panose="02070309020205020404" pitchFamily="49" charset="0"/>
               </a:rPr>
-              <a:t xml:space="preserve">, </a:t>
+              <a:t>, </a:t>
             </a:r>
             <a:r>
               <a:rPr lang="en-US" b="0" dirty="0">
@@ -1652,7 +1652,7 @@
                 <a:effectLst/>
                 <a:latin typeface="Courier New" panose="02070309020205020404" pitchFamily="49" charset="0"/>
               </a:rPr>
-              <a:t xml:space="preserve">, </a:t>
+              <a:t>, </a:t>
             </a:r>
             <a:r>
               <a:rPr lang="en-US" b="0" dirty="0">
@@ -1672,7 +1672,7 @@
                 <a:effectLst/>
                 <a:latin typeface="Courier New" panose="02070309020205020404" pitchFamily="49" charset="0"/>
               </a:rPr>
-              <a:t xml:space="preserve">, </a:t>
+              <a:t>, </a:t>
             </a:r>
             <a:r>
               <a:rPr lang="en-US" b="0" dirty="0">
@@ -1692,7 +1692,7 @@
                 <a:effectLst/>
                 <a:latin typeface="Courier New" panose="02070309020205020404" pitchFamily="49" charset="0"/>
               </a:rPr>
-              <a:t xml:space="preserve">, </a:t>
+              <a:t>, </a:t>
             </a:r>
             <a:r>
               <a:rPr lang="en-US" b="0" dirty="0">
@@ -1712,7 +1712,7 @@
                 <a:effectLst/>
                 <a:latin typeface="Courier New" panose="02070309020205020404" pitchFamily="49" charset="0"/>
               </a:rPr>
-              <a:t xml:space="preserve">, </a:t>
+              <a:t>, </a:t>
             </a:r>
             <a:r>
               <a:rPr lang="en-US" b="0" dirty="0">
@@ -1732,7 +1732,7 @@
                 <a:effectLst/>
                 <a:latin typeface="Courier New" panose="02070309020205020404" pitchFamily="49" charset="0"/>
               </a:rPr>
-              <a:t xml:space="preserve">, </a:t>
+              <a:t>, </a:t>
             </a:r>
             <a:r>
               <a:rPr lang="en-US" b="0" dirty="0">
@@ -1752,7 +1752,7 @@
                 <a:effectLst/>
                 <a:latin typeface="Courier New" panose="02070309020205020404" pitchFamily="49" charset="0"/>
               </a:rPr>
-              <a:t xml:space="preserve">, </a:t>
+              <a:t>, </a:t>
             </a:r>
             <a:r>
               <a:rPr lang="en-US" b="0" dirty="0">
@@ -1772,7 +1772,7 @@
                 <a:effectLst/>
                 <a:latin typeface="Courier New" panose="02070309020205020404" pitchFamily="49" charset="0"/>
               </a:rPr>
-              <a:t xml:space="preserve">, </a:t>
+              <a:t>, </a:t>
             </a:r>
             <a:r>
               <a:rPr lang="en-US" b="0" dirty="0" err="1">
@@ -1812,7 +1812,7 @@
                 <a:effectLst/>
                 <a:latin typeface="Courier New" panose="02070309020205020404" pitchFamily="49" charset="0"/>
               </a:rPr>
-              <a:t xml:space="preserve"> or </a:t>
+              <a:t> or </a:t>
             </a:r>
             <a:r>
               <a:rPr lang="en-US" b="0" dirty="0" err="1">
@@ -1852,7 +1852,7 @@
                 <a:effectLst/>
                 <a:latin typeface="Courier New" panose="02070309020205020404" pitchFamily="49" charset="0"/>
               </a:rPr>
-              <a:t xml:space="preserve"> Access</a:t>
+              <a:t> Access</a:t>
             </a:r>
           </a:p>
           <a:p>
@@ -1891,7 +1891,7 @@
                 <a:effectLst/>
                 <a:latin typeface="Courier New" panose="02070309020205020404" pitchFamily="49" charset="0"/>
               </a:rPr>
-              <a:t xml:space="preserve">, </a:t>
+              <a:t>, </a:t>
             </a:r>
             <a:r>
               <a:rPr lang="en-US" b="0" dirty="0">
@@ -1911,7 +1911,7 @@
                 <a:effectLst/>
                 <a:latin typeface="Courier New" panose="02070309020205020404" pitchFamily="49" charset="0"/>
               </a:rPr>
-              <a:t xml:space="preserve">, </a:t>
+              <a:t>, </a:t>
             </a:r>
             <a:r>
               <a:rPr lang="en-US" b="0" dirty="0">
@@ -1931,7 +1931,7 @@
                 <a:effectLst/>
                 <a:latin typeface="Courier New" panose="02070309020205020404" pitchFamily="49" charset="0"/>
               </a:rPr>
-              <a:t xml:space="preserve">, </a:t>
+              <a:t>, </a:t>
             </a:r>
             <a:r>
               <a:rPr lang="en-US" b="0" dirty="0">
@@ -1951,7 +1951,7 @@
                 <a:effectLst/>
                 <a:latin typeface="Courier New" panose="02070309020205020404" pitchFamily="49" charset="0"/>
               </a:rPr>
-              <a:t xml:space="preserve">, </a:t>
+              <a:t>, </a:t>
             </a:r>
             <a:r>
               <a:rPr lang="en-US" b="0" dirty="0">
@@ -1971,7 +1971,7 @@
                 <a:effectLst/>
                 <a:latin typeface="Courier New" panose="02070309020205020404" pitchFamily="49" charset="0"/>
               </a:rPr>
-              <a:t xml:space="preserve">, </a:t>
+              <a:t>, </a:t>
             </a:r>
             <a:r>
               <a:rPr lang="en-US" b="0" dirty="0">
@@ -2301,7 +2301,7 @@
           <a:p>
             <a:fld id="{0CC58D2E-84BF-0A44-9057-4674209F9D8F}" type="datetimeFigureOut">
               <a:rPr lang="en-US" smtClean="0"/>
-              <a:t>3/2/26</a:t>
+              <a:t>3/12/26</a:t>
             </a:fld>
             <a:endParaRPr lang="en-US"/>
           </a:p>
@@ -2512,7 +2512,7 @@
           <a:p>
             <a:fld id="{0CC58D2E-84BF-0A44-9057-4674209F9D8F}" type="datetimeFigureOut">
               <a:rPr lang="en-US" smtClean="0"/>
-              <a:t>3/2/26</a:t>
+              <a:t>3/12/26</a:t>
             </a:fld>
             <a:endParaRPr lang="en-US"/>
           </a:p>
@@ -2727,7 +2727,7 @@
           <a:p>
             <a:fld id="{0CC58D2E-84BF-0A44-9057-4674209F9D8F}" type="datetimeFigureOut">
               <a:rPr lang="en-US" smtClean="0"/>
-              <a:t>3/2/26</a:t>
+              <a:t>3/12/26</a:t>
             </a:fld>
             <a:endParaRPr lang="en-US"/>
           </a:p>
@@ -2928,7 +2928,7 @@
           <a:p>
             <a:fld id="{0CC58D2E-84BF-0A44-9057-4674209F9D8F}" type="datetimeFigureOut">
               <a:rPr lang="en-US" smtClean="0"/>
-              <a:t>3/2/26</a:t>
+              <a:t>3/12/26</a:t>
             </a:fld>
             <a:endParaRPr lang="en-US"/>
           </a:p>
@@ -3207,7 +3207,7 @@
           <a:p>
             <a:fld id="{0CC58D2E-84BF-0A44-9057-4674209F9D8F}" type="datetimeFigureOut">
               <a:rPr lang="en-US" smtClean="0"/>
-              <a:t>3/2/26</a:t>
+              <a:t>3/12/26</a:t>
             </a:fld>
             <a:endParaRPr lang="en-US"/>
           </a:p>
@@ -3475,7 +3475,7 @@
           <a:p>
             <a:fld id="{0CC58D2E-84BF-0A44-9057-4674209F9D8F}" type="datetimeFigureOut">
               <a:rPr lang="en-US" smtClean="0"/>
-              <a:t>3/2/26</a:t>
+              <a:t>3/12/26</a:t>
             </a:fld>
             <a:endParaRPr lang="en-US"/>
           </a:p>
@@ -3891,7 +3891,7 @@
           <a:p>
             <a:fld id="{0CC58D2E-84BF-0A44-9057-4674209F9D8F}" type="datetimeFigureOut">
               <a:rPr lang="en-US" smtClean="0"/>
-              <a:t>3/2/26</a:t>
+              <a:t>3/12/26</a:t>
             </a:fld>
             <a:endParaRPr lang="en-US"/>
           </a:p>
@@ -4040,7 +4040,7 @@
           <a:p>
             <a:fld id="{0CC58D2E-84BF-0A44-9057-4674209F9D8F}" type="datetimeFigureOut">
               <a:rPr lang="en-US" smtClean="0"/>
-              <a:t>3/2/26</a:t>
+              <a:t>3/12/26</a:t>
             </a:fld>
             <a:endParaRPr lang="en-US"/>
           </a:p>
@@ -4166,7 +4166,7 @@
           <a:p>
             <a:fld id="{0CC58D2E-84BF-0A44-9057-4674209F9D8F}" type="datetimeFigureOut">
               <a:rPr lang="en-US" smtClean="0"/>
-              <a:t>3/2/26</a:t>
+              <a:t>3/12/26</a:t>
             </a:fld>
             <a:endParaRPr lang="en-US"/>
           </a:p>
@@ -4417,7 +4417,7 @@
           <a:p>
             <a:fld id="{0CC58D2E-84BF-0A44-9057-4674209F9D8F}" type="datetimeFigureOut">
               <a:rPr lang="en-US" smtClean="0"/>
-              <a:t>3/2/26</a:t>
+              <a:t>3/12/26</a:t>
             </a:fld>
             <a:endParaRPr lang="en-US"/>
           </a:p>
@@ -4862,7 +4862,7 @@
           <a:p>
             <a:fld id="{0CC58D2E-84BF-0A44-9057-4674209F9D8F}" type="datetimeFigureOut">
               <a:rPr lang="en-US" smtClean="0"/>
-              <a:t>3/2/26</a:t>
+              <a:t>3/12/26</a:t>
             </a:fld>
             <a:endParaRPr lang="en-US"/>
           </a:p>
@@ -5196,7 +5196,7 @@
           <a:p>
             <a:fld id="{0CC58D2E-84BF-0A44-9057-4674209F9D8F}" type="datetimeFigureOut">
               <a:rPr lang="en-US" smtClean="0"/>
-              <a:t>3/2/26</a:t>
+              <a:t>3/12/26</a:t>
             </a:fld>
             <a:endParaRPr lang="en-US"/>
           </a:p>
@@ -5712,7 +5712,7 @@
           <a:p>
             <a:r>
               <a:rPr lang="en-US" sz="3200" dirty="0"/>
-              <a:t xml:space="preserve"> Analysis of the U.S. Apartment Rental Market: Identifying Key Segments and Characteristics</a:t>
+              <a:t> Analysis of the U.S. Apartment Rental Market: Identifying Key Segments and Characteristics</a:t>
             </a:r>
           </a:p>
         </p:txBody>
@@ -6228,15 +6228,7 @@
             </a:pPr>
             <a:r>
               <a:rPr lang="en-US" sz="1600" cap="all" dirty="0"/>
-              <a:t>https://ellac12345.github.io/</a:t>
-            </a:r>
-            <a:r>
-              <a:rPr lang="en-US" sz="1600" cap="all"/>
-              <a:t>US_Rental_Market</a:t>
-            </a:r>
-            <a:r>
-              <a:rPr lang="en-US" sz="1600" cap="all" dirty="0"/>
-              <a:t>/</a:t>
+              <a:t>https://ellan12-us-rental-market-srcapp-ujvkpx.streamlit.app/</a:t>
             </a:r>
           </a:p>
         </p:txBody>
@@ -6755,16 +6747,18 @@
         </p:nvSpPr>
         <p:spPr/>
         <p:txBody>
-          <a:bodyPr/>
+          <a:bodyPr>
+            <a:normAutofit fontScale="90000"/>
+          </a:bodyPr>
           <a:lstStyle/>
           <a:p>
             <a:r>
               <a:rPr lang="en-US" sz="3200" dirty="0"/>
-              <a:t xml:space="preserve">Results </a:t>
+              <a:t>Results </a:t>
             </a:r>
             <a:r>
               <a:rPr lang="en-US" sz="2000" dirty="0"/>
-              <a:t xml:space="preserve">cont’d :   </a:t>
+              <a:t>cont’d :   </a:t>
             </a:r>
             <a:r>
               <a:rPr lang="en-US" sz="3600" dirty="0"/>
@@ -6830,7 +6824,7 @@
             </a:pPr>
             <a:r>
               <a:rPr lang="en-US" sz="1800" dirty="0"/>
-              <a:t xml:space="preserve">Rental Price: </a:t>
+              <a:t>Rental Price: </a:t>
             </a:r>
           </a:p>
           <a:p>
@@ -6950,7 +6944,7 @@
             </a:pPr>
             <a:r>
               <a:rPr lang="en-US" dirty="0"/>
-              <a:t xml:space="preserve">Minimum : 0           </a:t>
+              <a:t>Minimum : 0           </a:t>
             </a:r>
           </a:p>
           <a:p>
@@ -7044,7 +7038,7 @@
             </a:pPr>
             <a:r>
               <a:rPr lang="en-US" dirty="0"/>
-              <a:t xml:space="preserve">Minimum : 0           </a:t>
+              <a:t>Minimum : 0           </a:t>
             </a:r>
           </a:p>
           <a:p>
@@ -7084,7 +7078,7 @@
             </a:pPr>
             <a:r>
               <a:rPr lang="en-US" dirty="0"/>
-              <a:t xml:space="preserve">Minimum : 0             </a:t>
+              <a:t>Minimum : 0             </a:t>
             </a:r>
           </a:p>
           <a:p>
@@ -7114,7 +7108,7 @@
             </a:pPr>
             <a:r>
               <a:rPr lang="en-US"/>
-              <a:t xml:space="preserve">Maximum: </a:t>
+              <a:t>Maximum: </a:t>
             </a:r>
             <a:r>
               <a:rPr lang="en-US" dirty="0"/>
@@ -7128,7 +7122,7 @@
             </a:pPr>
             <a:r>
               <a:rPr lang="en-US" dirty="0"/>
-              <a:t xml:space="preserve">Minimum: 0              </a:t>
+              <a:t>Minimum: 0              </a:t>
             </a:r>
           </a:p>
           <a:p>
@@ -7187,16 +7181,18 @@
         </p:nvSpPr>
         <p:spPr/>
         <p:txBody>
-          <a:bodyPr/>
+          <a:bodyPr>
+            <a:normAutofit fontScale="90000"/>
+          </a:bodyPr>
           <a:lstStyle/>
           <a:p>
             <a:r>
               <a:rPr lang="en-US" sz="3200" dirty="0"/>
-              <a:t xml:space="preserve">Results </a:t>
+              <a:t>Results </a:t>
             </a:r>
             <a:r>
               <a:rPr lang="en-US" sz="2000" dirty="0"/>
-              <a:t xml:space="preserve">cont’d    </a:t>
+              <a:t>cont’d    </a:t>
             </a:r>
             <a:r>
               <a:rPr lang="en-US" sz="3600" dirty="0"/>
@@ -7262,7 +7258,7 @@
             </a:pPr>
             <a:r>
               <a:rPr lang="en-US" sz="1800" dirty="0"/>
-              <a:t xml:space="preserve">Rental Price: </a:t>
+              <a:t>Rental Price: </a:t>
             </a:r>
           </a:p>
           <a:p>
@@ -7382,7 +7378,7 @@
             </a:pPr>
             <a:r>
               <a:rPr lang="en-US" dirty="0"/>
-              <a:t xml:space="preserve">Minimum : 0           </a:t>
+              <a:t>Minimum : 0           </a:t>
             </a:r>
           </a:p>
           <a:p>
@@ -7476,7 +7472,7 @@
             </a:pPr>
             <a:r>
               <a:rPr lang="en-US" dirty="0"/>
-              <a:t xml:space="preserve">Minimum : 0           </a:t>
+              <a:t>Minimum : 0           </a:t>
             </a:r>
           </a:p>
           <a:p>
@@ -7516,7 +7512,7 @@
             </a:pPr>
             <a:r>
               <a:rPr lang="en-US" dirty="0"/>
-              <a:t xml:space="preserve">Minimum : 3             </a:t>
+              <a:t>Minimum : 3             </a:t>
             </a:r>
           </a:p>
           <a:p>
@@ -7556,7 +7552,7 @@
             </a:pPr>
             <a:r>
               <a:rPr lang="en-US" dirty="0"/>
-              <a:t xml:space="preserve">Minimum: 0              </a:t>
+              <a:t>Minimum: 0              </a:t>
             </a:r>
           </a:p>
           <a:p>
@@ -7728,7 +7724,7 @@
             </a:r>
             <a:r>
               <a:rPr lang="en-US" sz="2100" dirty="0"/>
-              <a:t xml:space="preserve"> exclusively Cluster 1</a:t>
+              <a:t> exclusively Cluster 1</a:t>
             </a:r>
           </a:p>
           <a:p>
@@ -7885,7 +7881,7 @@
             </a:pPr>
             <a:r>
               <a:rPr lang="en-US" dirty="0"/>
-              <a:t xml:space="preserve">Machine Learning Methods: </a:t>
+              <a:t>Machine Learning Methods: </a:t>
             </a:r>
             <a:r>
               <a:rPr lang="en-US" dirty="0" err="1"/>
@@ -7893,7 +7889,7 @@
             </a:r>
             <a:r>
               <a:rPr lang="en-US" dirty="0"/>
-              <a:t xml:space="preserve"> Clustering, PCA analysis , </a:t>
+              <a:t> Clustering, PCA analysis , </a:t>
             </a:r>
             <a:r>
               <a:rPr lang="en-US" dirty="0" err="1"/>
@@ -7901,7 +7897,7 @@
             </a:r>
             <a:r>
               <a:rPr lang="en-US" dirty="0"/>
-              <a:t xml:space="preserve"> and </a:t>
+              <a:t> and </a:t>
             </a:r>
             <a:r>
               <a:rPr lang="en-US" dirty="0" err="1"/>
@@ -7909,7 +7905,7 @@
             </a:r>
             <a:r>
               <a:rPr lang="en-US" dirty="0"/>
-              <a:t xml:space="preserve"> </a:t>
+              <a:t> </a:t>
             </a:r>
           </a:p>
           <a:p>
@@ -7919,7 +7915,7 @@
             </a:pPr>
             <a:r>
               <a:rPr lang="en-US" dirty="0"/>
-              <a:t xml:space="preserve">Methodology Analysis </a:t>
+              <a:t>Methodology Analysis </a:t>
             </a:r>
           </a:p>
           <a:p>
@@ -7939,7 +7935,7 @@
             </a:pPr>
             <a:r>
               <a:rPr lang="en-US" dirty="0"/>
-              <a:t xml:space="preserve"> Q&amp;A session</a:t>
+              <a:t> Q&amp;A session</a:t>
             </a:r>
           </a:p>
         </p:txBody>
@@ -8130,7 +8126,7 @@
           <a:p>
             <a:r>
               <a:rPr lang="en-US" dirty="0"/>
-              <a:t xml:space="preserve">Data Source </a:t>
+              <a:t>Data Source </a:t>
             </a:r>
           </a:p>
         </p:txBody>
@@ -8326,7 +8322,7 @@
           <a:p>
             <a:r>
               <a:rPr lang="en-US" dirty="0"/>
-              <a:t xml:space="preserve">Used </a:t>
+              <a:t>Used </a:t>
             </a:r>
             <a:r>
               <a:rPr lang="en-US" dirty="0" err="1"/>
@@ -8334,7 +8330,7 @@
             </a:r>
             <a:r>
               <a:rPr lang="en-US" dirty="0"/>
-              <a:t xml:space="preserve"> method to scale numerical columns such as price, square feet, latitude and longitude</a:t>
+              <a:t> method to scale numerical columns such as price, square feet, latitude and longitude</a:t>
             </a:r>
           </a:p>
           <a:p>
@@ -8516,7 +8512,7 @@
             </a:r>
             <a:r>
               <a:rPr lang="en-US" dirty="0"/>
-              <a:t xml:space="preserve"> Clustering : 2 clusters identified</a:t>
+              <a:t> Clustering : 2 clusters identified</a:t>
             </a:r>
           </a:p>
           <a:p>
@@ -8647,7 +8643,7 @@
           <a:p>
             <a:r>
               <a:rPr lang="en-US" dirty="0"/>
-              <a:t xml:space="preserve">Machine Learning Methods </a:t>
+              <a:t>Machine Learning Methods </a:t>
             </a:r>
             <a:r>
               <a:rPr lang="en-US" sz="2000" dirty="0"/>
@@ -8688,7 +8684,7 @@
             </a:pPr>
             <a:r>
               <a:rPr lang="en-US" dirty="0"/>
-              <a:t xml:space="preserve">Principal Components Analysis : </a:t>
+              <a:t>Principal Components Analysis : </a:t>
             </a:r>
             <a:r>
               <a:rPr lang="en-US" dirty="0" err="1"/>
@@ -8817,7 +8813,7 @@
           <a:p>
             <a:r>
               <a:rPr lang="en-US" dirty="0"/>
-              <a:t xml:space="preserve">Machine Learning Methods </a:t>
+              <a:t>Machine Learning Methods </a:t>
             </a:r>
             <a:r>
               <a:rPr lang="en-US" sz="2000" dirty="0"/>
@@ -8863,7 +8859,7 @@
             </a:r>
             <a:r>
               <a:rPr lang="en-US" dirty="0"/>
-              <a:t xml:space="preserve"> and </a:t>
+              <a:t> and </a:t>
             </a:r>
             <a:r>
               <a:rPr lang="en-US" dirty="0" err="1"/>
@@ -8871,7 +8867,7 @@
             </a:r>
             <a:r>
               <a:rPr lang="en-US" dirty="0"/>
-              <a:t xml:space="preserve"> to determine feature importance on PCA method</a:t>
+              <a:t> to determine feature importance on PCA method</a:t>
             </a:r>
           </a:p>
           <a:p>
@@ -8995,7 +8991,7 @@
           <a:p>
             <a:r>
               <a:rPr lang="en-US" dirty="0"/>
-              <a:t xml:space="preserve">Machine Learning Methods </a:t>
+              <a:t>Machine Learning Methods </a:t>
             </a:r>
             <a:r>
               <a:rPr lang="en-US" sz="2000" dirty="0"/>
@@ -9036,7 +9032,7 @@
             </a:r>
             <a:r>
               <a:rPr lang="en-US" dirty="0"/>
-              <a:t xml:space="preserve"> and </a:t>
+              <a:t> and </a:t>
             </a:r>
             <a:r>
               <a:rPr lang="en-US" dirty="0" err="1"/>
@@ -9044,7 +9040,7 @@
             </a:r>
             <a:r>
               <a:rPr lang="en-US" dirty="0"/>
-              <a:t xml:space="preserve"> to determine feature importance on </a:t>
+              <a:t> to determine feature importance on </a:t>
             </a:r>
             <a:r>
               <a:rPr lang="en-US" dirty="0" err="1"/>
@@ -9052,7 +9048,7 @@
             </a:r>
             <a:r>
               <a:rPr lang="en-US" dirty="0"/>
-              <a:t xml:space="preserve"> method</a:t>
+              <a:t> method</a:t>
             </a:r>
           </a:p>
           <a:p>

</xml_diff>